<commit_message>
Contract v2: delivery + deadline-claim + refund-lock, 11/11 tests, verified Testnet flows, v2 docs/deck
</commit_message>
<xml_diff>
--- a/docs/safepay-pitch-deck.pptx
+++ b/docs/safepay-pitch-deck.pptx
@@ -3201,7 +3201,7 @@
               <a:rPr sz="1500" b="0">
                 <a:latin typeface="Calibri"/>
               </a:rPr>
-              <a:t>Team: Ronit Shrimankar (solo)</a:t>
+              <a:t>Team: FORTEC — Ronit Shrimankar (solo builder)</a:t>
             </a:r>
           </a:p>
           <a:p>
@@ -3234,7 +3234,7 @@
               <a:rPr sz="1500" b="0">
                 <a:latin typeface="Calibri"/>
               </a:rPr>
-              <a:t>DRAFT — not submitted. Testnet contract address and transaction hashes below are real, verified on-chain values (28 Oct 2026); remaining TBDs (demo link, repo, video, Mainnet) are filled only with real values when they exist.</a:t>
+              <a:t>DRAFT — not submitted. Testnet contract address and transaction hashes below are real, verified on-chain values (28 Oct 2026); remaining TBDs (video, Mainnet) are filled only with real values when they exist.</a:t>
             </a:r>
           </a:p>
         </p:txBody>
@@ -3543,7 +3543,7 @@
               <a:rPr sz="1500" b="0">
                 <a:latin typeface="Calibri"/>
               </a:rPr>
-              <a:t>2. The freelancer delivers milestone by milestone</a:t>
+              <a:t>2. The freelancer delivers milestone by milestone, recorded on-chain with proof</a:t>
             </a:r>
           </a:p>
           <a:p>
@@ -3569,7 +3569,7 @@
               <a:rPr sz="1500" b="0">
                 <a:latin typeface="Calibri"/>
               </a:rPr>
-              <a:t>4. Unreleased funds return to the client after the deadline</a:t>
+              <a:t>4. Unreleased, unapproved, undelivered funds return to the client after the deadline; delivered work is claimable by the freelancer instead</a:t>
             </a:r>
           </a:p>
           <a:p>
@@ -3676,134 +3676,74 @@
               <a:rPr sz="1500" b="0">
                 <a:latin typeface="Calibri"/>
               </a:rPr>
-              <a:t>1. </a:t>
-            </a:r>
-            <a:r>
-              <a:rPr sz="1500" b="1">
-                <a:latin typeface="Calibri"/>
-              </a:rPr>
-              <a:t>Create</a:t>
-            </a:r>
+              <a:t>Demo flow (every step is a real on-chain transaction)</a:t>
+            </a:r>
+          </a:p>
+          <a:p>
             <a:r>
               <a:rPr sz="1500" b="0">
                 <a:latin typeface="Calibri"/>
               </a:rPr>
-              <a:t> — client sets freelancer, milestone amounts, deadline</a:t>
-            </a:r>
-          </a:p>
-          <a:p>
-            <a:pPr>
-              <a:spcAft>
-                <a:spcPts val="400"/>
-              </a:spcAft>
-            </a:pPr>
+              <a:t>1. Create — client sets freelancer, milestone amounts, deadline</a:t>
+            </a:r>
+          </a:p>
+          <a:p>
             <a:r>
               <a:rPr sz="1500" b="0">
                 <a:latin typeface="Calibri"/>
               </a:rPr>
-              <a:t>2. </a:t>
-            </a:r>
-            <a:r>
-              <a:rPr sz="1500" b="1">
-                <a:latin typeface="Calibri"/>
-              </a:rPr>
-              <a:t>Fund</a:t>
-            </a:r>
+              <a:t>2. Fund — client locks exactly the milestone total into the contract</a:t>
+            </a:r>
+          </a:p>
+          <a:p>
             <a:r>
               <a:rPr sz="1500" b="0">
                 <a:latin typeface="Calibri"/>
               </a:rPr>
-              <a:t> — client locks exactly the milestone total into the contract</a:t>
-            </a:r>
-          </a:p>
-          <a:p>
-            <a:pPr>
-              <a:spcAft>
-                <a:spcPts val="400"/>
-              </a:spcAft>
-            </a:pPr>
+              <a:t>3. Deliver — freelancer records delivery on-chain with proof</a:t>
+            </a:r>
+          </a:p>
+          <a:p>
             <a:r>
               <a:rPr sz="1500" b="0">
                 <a:latin typeface="Calibri"/>
               </a:rPr>
-              <a:t>3. </a:t>
-            </a:r>
-            <a:r>
-              <a:rPr sz="1500" b="1">
-                <a:latin typeface="Calibri"/>
-              </a:rPr>
-              <a:t>Approve</a:t>
-            </a:r>
+              <a:t>4. Approve — client approves a delivered milestone (approval alone moves no funds)</a:t>
+            </a:r>
+          </a:p>
+          <a:p>
             <a:r>
               <a:rPr sz="1500" b="0">
                 <a:latin typeface="Calibri"/>
               </a:rPr>
-              <a:t> — client approves a delivered milestone (approval alone moves no funds)</a:t>
-            </a:r>
-          </a:p>
-          <a:p>
-            <a:pPr>
-              <a:spcAft>
-                <a:spcPts val="400"/>
-              </a:spcAft>
-            </a:pPr>
+              <a:t>5. Release — the approved milestone’s payment goes to the freelancer</a:t>
+            </a:r>
+          </a:p>
+          <a:p>
             <a:r>
               <a:rPr sz="1500" b="0">
                 <a:latin typeface="Calibri"/>
               </a:rPr>
-              <a:t>4. </a:t>
-            </a:r>
-            <a:r>
-              <a:rPr sz="1500" b="1">
-                <a:latin typeface="Calibri"/>
-              </a:rPr>
-              <a:t>Release</a:t>
-            </a:r>
+              <a:t>6. Claim — after the deadline, delivered-but-unapproved work is claimable by the freelancer</a:t>
+            </a:r>
+          </a:p>
+          <a:p>
             <a:r>
               <a:rPr sz="1500" b="0">
                 <a:latin typeface="Calibri"/>
               </a:rPr>
-              <a:t> — the approved milestone's payment goes to the freelancer</a:t>
-            </a:r>
-          </a:p>
-          <a:p>
-            <a:pPr>
-              <a:spcAft>
-                <a:spcPts val="400"/>
-              </a:spcAft>
-            </a:pPr>
+              <a:t>7. Refund — after the deadline, only unapproved, undelivered funds return to the client</a:t>
+            </a:r>
+          </a:p>
+          <a:p>
             <a:r>
               <a:rPr sz="1500" b="0">
                 <a:latin typeface="Calibri"/>
               </a:rPr>
-              <a:t>5. </a:t>
-            </a:r>
-            <a:r>
-              <a:rPr sz="1500" b="1">
-                <a:latin typeface="Calibri"/>
-              </a:rPr>
-              <a:t>Refund</a:t>
-            </a:r>
-            <a:r>
-              <a:rPr sz="1500" b="0">
-                <a:latin typeface="Calibri"/>
-              </a:rPr>
-              <a:t> — after the deadline, unreleased funds return to the client</a:t>
-            </a:r>
-          </a:p>
-          <a:p>
-            <a:pPr>
-              <a:spcAft>
-                <a:spcPts val="400"/>
-              </a:spcAft>
-            </a:pPr>
-          </a:p>
-          <a:p>
-            <a:pPr>
-              <a:spcAft>
-                <a:spcPts val="400"/>
-              </a:spcAft>
-            </a:pPr>
+              <a:t/>
+            </a:r>
+          </a:p>
+          <a:p>
             <a:r>
               <a:rPr sz="1500" b="0">
                 <a:latin typeface="Calibri"/>
@@ -4177,7 +4117,7 @@
               <a:rPr sz="1300" b="0">
                 <a:latin typeface="Calibri"/>
               </a:rPr>
-              <a:t>•  Every state change (create, fund, approve, release, refund) is a transaction with a verifiable hash</a:t>
+              <a:t>•  Every state change (create, fund, approve, deliver, release, claim, refund) is a transaction with a verifiable hash</a:t>
             </a:r>
           </a:p>
           <a:p>
@@ -4190,7 +4130,7 @@
               <a:rPr sz="1300" b="0">
                 <a:latin typeface="Calibri"/>
               </a:rPr>
-              <a:t>•  The contract enforces the rules: exact funding amount, client-only funding/approval/refund, no double release, no refund before the deadline</a:t>
+              <a:t>•  The contract enforces the rules: exact funding amount, client-only funding/approval/refund, no double release, no refund before the deadline, approved/delivered funds locked against refunds</a:t>
             </a:r>
           </a:p>
           <a:p>
@@ -4203,7 +4143,7 @@
               <a:rPr sz="1300" b="0">
                 <a:latin typeface="Calibri"/>
               </a:rPr>
-              <a:t>•  Anyone can read escrow state on-chain (getEscrow, getMilestone) and audit events (EscrowCreated, EscrowFunded, MilestoneApproved, MilestoneReleased, EscrowRefunded)</a:t>
+              <a:t>•  Anyone can read escrow state on-chain (getEscrow, getMilestone) and audit events (EscrowCreated, EscrowFunded, MilestoneApproved, MilestoneDelivered, MilestoneReleased, EscrowRefunded)</a:t>
             </a:r>
           </a:p>
           <a:p>
@@ -4579,7 +4519,7 @@
                       </a:pPr>
                       <a:r>
                         <a:rPr sz="1100"/>
-                        <a:t>Returns all still-unreleased funds to the client</a:t>
+                        <a:t>Returns only unapproved, undelivered funds; approved/delivered funds are locked</a:t>
                       </a:r>
                     </a:p>
                   </a:txBody>
@@ -4636,6 +4576,106 @@
                   <a:tcPr/>
                 </a:tc>
               </a:tr>
+              <a:tr h="718457">
+                <a:tc>
+                  <a:txBody>
+                    <a:bodyPr/>
+                    <a:lstStyle/>
+                    <a:p>
+                      <a:pPr>
+                        <a:defRPr sz="1100"/>
+                      </a:pPr>
+                      <a:r>
+                        <a:rPr sz="1100"/>
+                        <a:t>submitDelivery(escrowId, index, proof)</a:t>
+                      </a:r>
+                    </a:p>
+                  </a:txBody>
+                  <a:tcPr/>
+                </a:tc>
+                <a:tc>
+                  <a:txBody>
+                    <a:bodyPr/>
+                    <a:lstStyle/>
+                    <a:p>
+                      <a:pPr>
+                        <a:defRPr sz="1100"/>
+                      </a:pPr>
+                      <a:r>
+                        <a:rPr sz="1100"/>
+                        <a:t>freelancer only, before deadline</a:t>
+                      </a:r>
+                    </a:p>
+                  </a:txBody>
+                  <a:tcPr/>
+                </a:tc>
+                <a:tc>
+                  <a:txBody>
+                    <a:bodyPr/>
+                    <a:lstStyle/>
+                    <a:p>
+                      <a:pPr>
+                        <a:defRPr sz="1100"/>
+                      </a:pPr>
+                      <a:r>
+                        <a:rPr sz="1100"/>
+                        <a:t>Records delivery on-chain with a proof link; moves no funds by itself</a:t>
+                      </a:r>
+                    </a:p>
+                  </a:txBody>
+                  <a:tcPr/>
+                </a:tc>
+              </a:tr>
+              <a:tr h="718457">
+                <a:tc>
+                  <a:txBody>
+                    <a:bodyPr/>
+                    <a:lstStyle/>
+                    <a:p>
+                      <a:pPr>
+                        <a:defRPr sz="1100"/>
+                      </a:pPr>
+                      <a:r>
+                        <a:rPr sz="1100"/>
+                        <a:t>claimDelivered(escrowId, index)</a:t>
+                      </a:r>
+                    </a:p>
+                  </a:txBody>
+                  <a:tcPr/>
+                </a:tc>
+                <a:tc>
+                  <a:txBody>
+                    <a:bodyPr/>
+                    <a:lstStyle/>
+                    <a:p>
+                      <a:pPr>
+                        <a:defRPr sz="1100"/>
+                      </a:pPr>
+                      <a:r>
+                        <a:rPr sz="1100"/>
+                        <a:t>freelancer only, after deadline</a:t>
+                      </a:r>
+                    </a:p>
+                  </a:txBody>
+                  <a:tcPr/>
+                </a:tc>
+                <a:tc>
+                  <a:txBody>
+                    <a:bodyPr/>
+                    <a:lstStyle/>
+                    <a:p>
+                      <a:pPr>
+                        <a:defRPr sz="1100"/>
+                      </a:pPr>
+                      <a:r>
+                        <a:rPr sz="1100"/>
+                        <a:t>Pays delivered-but-unapproved work; the anti-ghosting path</a:t>
+                      </a:r>
+                    </a:p>
+                  </a:txBody>
+                  <a:tcPr/>
+                </a:tc>
+              </a:tr>
             </a:tbl>
           </a:graphicData>
         </a:graphic>
@@ -4824,7 +4864,7 @@
               <a:rPr sz="1500" b="0">
                 <a:latin typeface="Calibri"/>
               </a:rPr>
-              <a:t>Future work (not built yet): platform fees, multi-freelancer escrows, mediation for disputed milestones. The MVP proves the core — on-chain custody and release — first.</a:t>
+              <a:t>Future work (not built yet): platform fees, multi-freelancer escrows, third-party arbitration. Delivery proof and deadline-claim are already built. The MVP proves the core — on-chain custody and release — first.</a:t>
             </a:r>
           </a:p>
         </p:txBody>
@@ -4915,496 +4955,163 @@
             </a:r>
           </a:p>
           <a:p>
-            <a:pPr>
-              <a:spcAft>
-                <a:spcPts val="400"/>
-              </a:spcAft>
-            </a:pPr>
-          </a:p>
-          <a:p>
-            <a:pPr>
-              <a:spcAft>
-                <a:spcPts val="400"/>
-              </a:spcAft>
-            </a:pPr>
-            <a:r>
-              <a:rPr sz="1200" b="0">
+            <a:r>
+              <a:rPr sz="1200" b="1">
+                <a:latin typeface="Calibri"/>
+              </a:rPr>
+              <a:t/>
+            </a:r>
+          </a:p>
+          <a:p>
+            <a:r>
+              <a:rPr sz="1200" b="1">
                 <a:latin typeface="Calibri"/>
               </a:rPr>
               <a:t>•  Contract compiles cleanly (Solidity 0.8.24)</a:t>
             </a:r>
           </a:p>
           <a:p>
-            <a:pPr>
-              <a:spcAft>
-                <a:spcPts val="400"/>
-              </a:spcAft>
-            </a:pPr>
-            <a:r>
-              <a:rPr sz="1200" b="0">
-                <a:latin typeface="Calibri"/>
-              </a:rPr>
-              <a:t>•  6/6 Hardhat tests passing: create (+ bad-input reverts), fund rules, approve + release (exact payment, no double-spend), refund rules, full end-to-end flow</a:t>
-            </a:r>
-          </a:p>
-          <a:p>
-            <a:pPr>
-              <a:spcAft>
-                <a:spcPts val="400"/>
-              </a:spcAft>
-            </a:pPr>
-            <a:r>
-              <a:rPr sz="1200" b="0">
-                <a:latin typeface="Calibri"/>
-              </a:rPr>
-              <a:t>•  Local-node end-to-end run passed (local network only — </a:t>
-            </a:r>
             <a:r>
               <a:rPr sz="1200" b="1">
                 <a:latin typeface="Calibri"/>
               </a:rPr>
-              <a:t>not</a:t>
-            </a:r>
-            <a:r>
-              <a:rPr sz="1200" b="0">
-                <a:latin typeface="Calibri"/>
-              </a:rPr>
-              <a:t> testnet proof)</a:t>
-            </a:r>
-          </a:p>
-          <a:p>
-            <a:pPr>
-              <a:spcAft>
-                <a:spcPts val="400"/>
-              </a:spcAft>
-            </a:pPr>
-          </a:p>
-          <a:p>
-            <a:pPr>
-              <a:spcAft>
-                <a:spcPts val="400"/>
-              </a:spcAft>
-            </a:pPr>
+              <a:t>•  11/11 Hardhat tests passing: v1 flows plus v2 delivery rules, deadline-claim, and refund-lock (partial + full)</a:t>
+            </a:r>
+          </a:p>
+          <a:p>
             <a:r>
               <a:rPr sz="1200" b="1">
                 <a:latin typeface="Calibri"/>
               </a:rPr>
+              <a:t>•  Local-node end-to-end run passed (local network only — not testnet proof)</a:t>
+            </a:r>
+          </a:p>
+          <a:p>
+            <a:r>
+              <a:rPr sz="1200" b="1">
+                <a:latin typeface="Calibri"/>
+              </a:rPr>
+              <a:t/>
+            </a:r>
+          </a:p>
+          <a:p>
+            <a:r>
+              <a:rPr sz="1200" b="1">
+                <a:latin typeface="Calibri"/>
+              </a:rPr>
               <a:t>Testnet deployment — DONE and verified on-chain (28 Oct 2026, MST Testnet, chain ID 91562037):</a:t>
             </a:r>
           </a:p>
           <a:p>
-            <a:pPr>
-              <a:spcAft>
-                <a:spcPts val="400"/>
-              </a:spcAft>
-            </a:pPr>
-          </a:p>
-          <a:p>
-            <a:pPr>
-              <a:spcAft>
-                <a:spcPts val="400"/>
-              </a:spcAft>
-            </a:pPr>
-            <a:r>
-              <a:rPr sz="1200" b="0">
-                <a:latin typeface="Calibri"/>
-              </a:rPr>
-              <a:t>•  Testnet contract address: </a:t>
-            </a:r>
             <a:r>
               <a:rPr sz="1200" b="1">
                 <a:latin typeface="Calibri"/>
               </a:rPr>
-              <a:t>0xd330F3F7cD35FA2512592dCC0aD75381aF3798F5</a:t>
-            </a:r>
-            <a:r>
-              <a:rPr sz="1200" b="0">
-                <a:latin typeface="Calibri"/>
-              </a:rPr>
-              <a:t> — https://testnet.mstscan.com/address/0xd330F3F7cD35FA2512592dCC0aD75381aF3798F5</a:t>
-            </a:r>
-          </a:p>
-          <a:p>
-            <a:pPr>
-              <a:spcAft>
-                <a:spcPts val="400"/>
-              </a:spcAft>
-            </a:pPr>
-            <a:r>
-              <a:rPr sz="1200" b="0">
-                <a:latin typeface="Calibri"/>
-              </a:rPr>
-              <a:t>•  Deploy tx: </a:t>
-            </a:r>
+              <a:t/>
+            </a:r>
+          </a:p>
+          <a:p>
             <a:r>
               <a:rPr sz="1200" b="1">
                 <a:latin typeface="Calibri"/>
               </a:rPr>
-              <a:t>0x7843d0788f8781eda9cf665ad361382c0b42cca29d484ed6a6d3b14313e6d5a6</a:t>
-            </a:r>
-            <a:r>
-              <a:rPr sz="1200" b="0">
-                <a:latin typeface="Calibri"/>
-              </a:rPr>
-              <a:t> (block 6634177)</a:t>
-            </a:r>
-          </a:p>
-          <a:p>
-            <a:pPr>
-              <a:spcAft>
-                <a:spcPts val="400"/>
-              </a:spcAft>
-            </a:pPr>
-            <a:r>
-              <a:rPr sz="1200" b="0">
-                <a:latin typeface="Calibri"/>
-              </a:rPr>
-              <a:t>•  createEscrow(0): </a:t>
-            </a:r>
+              <a:t>•  Testnet contract address (v2): 0x40854b8c2436504FFB30Ac89298Da24eC434a905 — https://testnet.mstscan.com/address/0x40854b8c2436504FFB30Ac89298Da24eC434a905</a:t>
+            </a:r>
+          </a:p>
+          <a:p>
             <a:r>
               <a:rPr sz="1200" b="1">
                 <a:latin typeface="Calibri"/>
               </a:rPr>
-              <a:t>0xcb04b4620a87c271a81cdecd35c41d3669e0a948aa8fcfa3e7110d474bf02c97</a:t>
-            </a:r>
-            <a:r>
-              <a:rPr sz="1200" b="0">
-                <a:latin typeface="Calibri"/>
-              </a:rPr>
-              <a:t> (block 6634184)</a:t>
-            </a:r>
-          </a:p>
-          <a:p>
-            <a:pPr>
-              <a:spcAft>
-                <a:spcPts val="400"/>
-              </a:spcAft>
-            </a:pPr>
-            <a:r>
-              <a:rPr sz="1200" b="0">
-                <a:latin typeface="Calibri"/>
-              </a:rPr>
-              <a:t>•  fund(0) — 1.0 tMSTC: </a:t>
-            </a:r>
+              <a:t>•  Deploy tx (v2): 0x6e52a3661e5a044893ce16153c6005458f9b5ea15f953d3fb78e6ead8a185fde (block 6636444)</a:t>
+            </a:r>
+          </a:p>
+          <a:p>
             <a:r>
               <a:rPr sz="1200" b="1">
                 <a:latin typeface="Calibri"/>
               </a:rPr>
-              <a:t>0x8cc61e2a097946d60ebff2d3bb78d0353dfc3b9dfe6ed56bea16882ff54796f6</a:t>
-            </a:r>
-            <a:r>
-              <a:rPr sz="1200" b="0">
-                <a:latin typeface="Calibri"/>
-              </a:rPr>
-              <a:t> (block 6634185)</a:t>
-            </a:r>
-          </a:p>
-          <a:p>
-            <a:pPr>
-              <a:spcAft>
-                <a:spcPts val="400"/>
-              </a:spcAft>
-            </a:pPr>
-            <a:r>
-              <a:rPr sz="1200" b="0">
-                <a:latin typeface="Calibri"/>
-              </a:rPr>
-              <a:t>•  approveMilestone(0,0): </a:t>
-            </a:r>
+              <a:t>•  Escrow 0 — approve/release flow, 1.0 tMSTC released: create 0xf858ba38563de2bb63557444afb0fbad89673e0af621fba969e474e5f950cc3c, fund 0x9fa2ecc82171bb83f24c762faed7da34dc908d07759eb11fa468f42415bc82ef, approve 0x6c66730ff8a957e7deb2d7bbf2037aab767ee140289cec5f31cbd9c0d62ebddb, release 0x0ad76f8200adebc9706dbfe5e1acefbc1af6bf75a15f41aa2831ada0ce903a91, approve 0x0092e15702275a5f3739695f7d95e89cf7d791820f49b01269b01fbe8e6317b5, release 0x5e95af131e29c98b2585e476d96f9740a220b8e94caa57a67f23f8de5db9aef4</a:t>
+            </a:r>
+          </a:p>
+          <a:p>
             <a:r>
               <a:rPr sz="1200" b="1">
                 <a:latin typeface="Calibri"/>
               </a:rPr>
-              <a:t>0xd989e5a12c6b273b20bc3dd26f0d06c67baac4df765591d7b5ca62388f799614</a:t>
-            </a:r>
-            <a:r>
-              <a:rPr sz="1200" b="0">
-                <a:latin typeface="Calibri"/>
-              </a:rPr>
-              <a:t> (block 6634186)</a:t>
-            </a:r>
-          </a:p>
-          <a:p>
-            <a:pPr>
-              <a:spcAft>
-                <a:spcPts val="400"/>
-              </a:spcAft>
-            </a:pPr>
-            <a:r>
-              <a:rPr sz="1200" b="0">
-                <a:latin typeface="Calibri"/>
-              </a:rPr>
-              <a:t>•  releaseMilestone(0,0) — 0.6 tMSTC paid: </a:t>
-            </a:r>
+              <a:t>•  Escrow 1 — refund path, 0.5 tMSTC returned: create 0x063ada4f597a54965720657f850a8aabc8db4da80483006e05ee9b243fe3a65a, fund 0x233281aec91bd9506944af7089cadb7b1948ef263b5dbb741ade340d73754b1c, refund 0xc136c1b9fdfc75eae0f4da53ac3d715c8f073c663e09f9bf273190305ed94fa2</a:t>
+            </a:r>
+          </a:p>
+          <a:p>
             <a:r>
               <a:rPr sz="1200" b="1">
                 <a:latin typeface="Calibri"/>
               </a:rPr>
-              <a:t>0xed56b2e2a5ca61db25d9e6ebca393d4e20578fb89b436dfd309272a4e2b08fd3</a:t>
-            </a:r>
-            <a:r>
-              <a:rPr sz="1200" b="0">
-                <a:latin typeface="Calibri"/>
-              </a:rPr>
-              <a:t> (block 6634187)</a:t>
-            </a:r>
-          </a:p>
-          <a:p>
-            <a:pPr>
-              <a:spcAft>
-                <a:spcPts val="400"/>
-              </a:spcAft>
-            </a:pPr>
-            <a:r>
-              <a:rPr sz="1200" b="0">
-                <a:latin typeface="Calibri"/>
-              </a:rPr>
-              <a:t>•  approveMilestone(0,1): </a:t>
-            </a:r>
+              <a:t>•  Escrow 2 — delivery + deadline-claim, 0.5 tMSTC claimed with no approval: create 0x20d7b3786e2b735ee0bb5370d457147019d6cf0ffe7327883187e93d61828322, fund 0x634636255f5a43de502152500be599bdd31e38bf0d8b2fc5207c7b64bc795e61, deliver 0x26fbc6190634d8a187c78bf891857ee40a21ef1a0bd119a77f9fc55c0fc47352, claim 0x79687f07a2c5d330aa1a63d4baddb8c9971aa78911895a226688b7d1b22ce7a7</a:t>
+            </a:r>
+          </a:p>
+          <a:p>
             <a:r>
               <a:rPr sz="1200" b="1">
                 <a:latin typeface="Calibri"/>
               </a:rPr>
-              <a:t>0xb4b8265d3600f7dbc9ef1ac8dcfa1256f853ad51cd82296b68d8336d60b23aeb</a:t>
-            </a:r>
-            <a:r>
-              <a:rPr sz="1200" b="0">
-                <a:latin typeface="Calibri"/>
-              </a:rPr>
-              <a:t> (block 6634188)</a:t>
-            </a:r>
-          </a:p>
-          <a:p>
-            <a:pPr>
-              <a:spcAft>
-                <a:spcPts val="400"/>
-              </a:spcAft>
-            </a:pPr>
-            <a:r>
-              <a:rPr sz="1200" b="0">
-                <a:latin typeface="Calibri"/>
-              </a:rPr>
-              <a:t>•  releaseMilestone(0,1) — 0.4 tMSTC paid: </a:t>
-            </a:r>
+              <a:t>•  Escrow 3 — refund-lock, 0.6 released + 0.6 refunded + 0.4 claimed (delivered funds NOT swept): create 0xc5693a6e957d67e7e220a336eee2d6d29d5e2bc1b07dcf735bd3b4e838d073f1, fund 0xb5783109d7d65ff422a0adf9006e032003237f5df6137d99cca808a7b9f942ca, deliver 0xa2d2d116d5276b2b07bf5b5884251e2b5d7ca0b3bc1cc297bd9968f2acd91a5a, approve 0x7c8155647ea58295dde6279a8b5cef32cd5145a5501915c3beb4a4ef65f7110d, release 0x40d585b97fb26a9ebd4fa54e3f4492496d19eb55871bbb4a28c43c3538c2a2fb, refund 0x043afd53052c8475c176090d8499d56f1981b6537623ed8d4f98f33cd5d23962, claim 0x1b6de3266d7b0cd1beb9e32fb4b811d5e990cce515f87598e606e5206eb0796f</a:t>
+            </a:r>
+          </a:p>
+          <a:p>
             <a:r>
               <a:rPr sz="1200" b="1">
                 <a:latin typeface="Calibri"/>
               </a:rPr>
-              <a:t>0x02265040e5958643db3ab81070701297b2f209f22fafef8b1601eb8344840af7</a:t>
-            </a:r>
-            <a:r>
-              <a:rPr sz="1200" b="0">
-                <a:latin typeface="Calibri"/>
-              </a:rPr>
-              <a:t> (block 6634189)</a:t>
-            </a:r>
-          </a:p>
-          <a:p>
-            <a:pPr>
-              <a:spcAft>
-                <a:spcPts val="400"/>
-              </a:spcAft>
-            </a:pPr>
-            <a:r>
-              <a:rPr sz="1200" b="0">
-                <a:latin typeface="Calibri"/>
-              </a:rPr>
-              <a:t>•  createEscrow(1) — refund path: </a:t>
-            </a:r>
+              <a:t>•  All 22 receipts confirmed successful (status 0x1) via the official Testnet RPC; contract bytecode verified on-chain; final states re-read on-chain.</a:t>
+            </a:r>
+          </a:p>
+          <a:p>
             <a:r>
               <a:rPr sz="1200" b="1">
                 <a:latin typeface="Calibri"/>
               </a:rPr>
-              <a:t>0x52513072e3a27a06f9fe7c916098df10e4978087b1c37276bfa91b5e8322fdfe</a:t>
-            </a:r>
-            <a:r>
-              <a:rPr sz="1200" b="0">
-                <a:latin typeface="Calibri"/>
-              </a:rPr>
-              <a:t> (block 6634190)</a:t>
-            </a:r>
-          </a:p>
-          <a:p>
-            <a:pPr>
-              <a:spcAft>
-                <a:spcPts val="400"/>
-              </a:spcAft>
-            </a:pPr>
-            <a:r>
-              <a:rPr sz="1200" b="0">
-                <a:latin typeface="Calibri"/>
-              </a:rPr>
-              <a:t>•  fund(1) — 0.5 tMSTC: </a:t>
-            </a:r>
+              <a:t>•  Live demo link: https://eres0045.github.io/safepay/app/</a:t>
+            </a:r>
+          </a:p>
+          <a:p>
             <a:r>
               <a:rPr sz="1200" b="1">
                 <a:latin typeface="Calibri"/>
               </a:rPr>
-              <a:t>0x9a04c4d9f47bc1babdc93d2ee33799a161fd0fdde6a7cfaedf38752503abacac</a:t>
-            </a:r>
-            <a:r>
-              <a:rPr sz="1200" b="0">
-                <a:latin typeface="Calibri"/>
-              </a:rPr>
-              <a:t> (block 6634191)</a:t>
-            </a:r>
-          </a:p>
-          <a:p>
-            <a:pPr>
-              <a:spcAft>
-                <a:spcPts val="400"/>
-              </a:spcAft>
-            </a:pPr>
-            <a:r>
-              <a:rPr sz="1200" b="0">
-                <a:latin typeface="Calibri"/>
-              </a:rPr>
-              <a:t>•  refund(1) — 0.5 tMSTC returned: </a:t>
-            </a:r>
+              <a:t>•  Public GitHub repository: https://github.com/eres0045/safepay</a:t>
+            </a:r>
+          </a:p>
+          <a:p>
             <a:r>
               <a:rPr sz="1200" b="1">
                 <a:latin typeface="Calibri"/>
               </a:rPr>
-              <a:t>0xd64105d11df29d1d0de8c68e550ffe72e30920803412d7a388ed445f471cdb9d</a:t>
-            </a:r>
-            <a:r>
-              <a:rPr sz="1200" b="0">
-                <a:latin typeface="Calibri"/>
-              </a:rPr>
-              <a:t> (block 6634192)</a:t>
-            </a:r>
-          </a:p>
-          <a:p>
-            <a:pPr>
-              <a:spcAft>
-                <a:spcPts val="400"/>
-              </a:spcAft>
-            </a:pPr>
-            <a:r>
-              <a:rPr sz="1200" b="0">
-                <a:latin typeface="Calibri"/>
-              </a:rPr>
-              <a:t>•  All 10 receipts confirmed successful (status 0x1) via the official Testnet RPC; contract bytecode verified on-chain. Explorer page fetch timed out and was not retried — verify visually at the links above.</a:t>
-            </a:r>
-          </a:p>
-          <a:p>
-            <a:pPr>
-              <a:spcAft>
-                <a:spcPts val="400"/>
-              </a:spcAft>
-            </a:pPr>
-            <a:r>
-              <a:rPr sz="1200" b="0">
-                <a:latin typeface="Calibri"/>
-              </a:rPr>
-              <a:t>•  Live demo link: </a:t>
-            </a:r>
+              <a:t>•  Demo video (2–3 min): TBD</a:t>
+            </a:r>
+          </a:p>
+          <a:p>
             <a:r>
               <a:rPr sz="1200" b="1">
                 <a:latin typeface="Calibri"/>
               </a:rPr>
-              <a:t>TBD</a:t>
-            </a:r>
-          </a:p>
-          <a:p>
-            <a:pPr>
-              <a:spcAft>
-                <a:spcPts val="400"/>
-              </a:spcAft>
-            </a:pPr>
-            <a:r>
-              <a:rPr sz="1200" b="0">
-                <a:latin typeface="Calibri"/>
-              </a:rPr>
-              <a:t>•  Public GitHub repository: </a:t>
-            </a:r>
+              <a:t>•  Mainnet deployment details: TBD (organizer-provided funds)</a:t>
+            </a:r>
+          </a:p>
+          <a:p>
             <a:r>
               <a:rPr sz="1200" b="1">
                 <a:latin typeface="Calibri"/>
               </a:rPr>
-              <a:t>TBD</a:t>
-            </a:r>
-          </a:p>
-          <a:p>
-            <a:pPr>
-              <a:spcAft>
-                <a:spcPts val="400"/>
-              </a:spcAft>
-            </a:pPr>
-            <a:r>
-              <a:rPr sz="1200" b="0">
-                <a:latin typeface="Calibri"/>
-              </a:rPr>
-              <a:t>•  Demo video (2–3 min): </a:t>
-            </a:r>
+              <a:t/>
+            </a:r>
+          </a:p>
+          <a:p>
             <a:r>
               <a:rPr sz="1200" b="1">
                 <a:latin typeface="Calibri"/>
               </a:rPr>
-              <a:t>TBD</a:t>
-            </a:r>
-          </a:p>
-          <a:p>
-            <a:pPr>
-              <a:spcAft>
-                <a:spcPts val="400"/>
-              </a:spcAft>
-            </a:pPr>
-            <a:r>
-              <a:rPr sz="1200" b="0">
-                <a:latin typeface="Calibri"/>
-              </a:rPr>
-              <a:t>•  Mainnet deployment details: </a:t>
-            </a:r>
-            <a:r>
-              <a:rPr sz="1200" b="1">
-                <a:latin typeface="Calibri"/>
-              </a:rPr>
-              <a:t>TBD</a:t>
-            </a:r>
-            <a:r>
-              <a:rPr sz="1200" b="0">
-                <a:latin typeface="Calibri"/>
-              </a:rPr>
-              <a:t> (organizer-provided funds)</a:t>
-            </a:r>
-          </a:p>
-          <a:p>
-            <a:pPr>
-              <a:spcAft>
-                <a:spcPts val="400"/>
-              </a:spcAft>
-            </a:pPr>
-          </a:p>
-          <a:p>
-            <a:pPr>
-              <a:spcAft>
-                <a:spcPts val="400"/>
-              </a:spcAft>
-            </a:pPr>
-            <a:r>
-              <a:rPr sz="1200" b="0">
-                <a:latin typeface="Calibri"/>
-              </a:rPr>
-              <a:t>Round 2 submission deadline: </a:t>
-            </a:r>
-            <a:r>
-              <a:rPr sz="1200" b="1">
-                <a:latin typeface="Calibri"/>
-              </a:rPr>
-              <a:t>30 Oct 2026, 12:00 PM IST</a:t>
-            </a:r>
-            <a:r>
-              <a:rPr sz="1200" b="0">
-                <a:latin typeface="Calibri"/>
-              </a:rPr>
-              <a:t> · Demo Day: </a:t>
-            </a:r>
-            <a:r>
-              <a:rPr sz="1200" b="1">
-                <a:latin typeface="Calibri"/>
-              </a:rPr>
-              <a:t>1 Nov 2026, MST office Pune</a:t>
+              <a:t>Round 2 submission deadline: 30 Oct 2026, 12:00 PM IST · Demo Day: 1 Nov 2026, MST office Pune</a:t>
             </a:r>
           </a:p>
         </p:txBody>

</xml_diff>